<commit_message>
Ispravljen vremenski okvir: sve završeno do kraja augusta, prije septembarskog roka
</commit_message>
<xml_diff>
--- a/public/docs/CityIce-prezentacija.pptx
+++ b/public/docs/CityIce-prezentacija.pptx
@@ -4840,7 +4840,7 @@
                 <a:ea typeface="Arial" pitchFamily="34" charset="-122"/>
                 <a:cs typeface="Arial" pitchFamily="34" charset="-120"/>
               </a:rPr>
-              <a:t>Projekat mora biti gotov u toku semestra, prije novogodišnje sezone, i sve radi jedna osoba. Zato je obim svjesno sužen na aktivnosti s najvećim efektom: bolje tri stvari završene do kraja, nego deset započetih.</a:t>
+              <a:t>Cijeli projekat je morao biti završen do kraja augusta, prije septembarskog roka, i sve radi jedna osoba. Zato je obim svjesno sužen na aktivnosti s najvećim efektom: bolje tri stvari završene do kraja, nego deset započetih.</a:t>
             </a:r>
             <a:endParaRPr lang="en-US" sz="1350" dirty="0"/>
           </a:p>
@@ -5392,7 +5392,7 @@
                 <a:ea typeface="Arial" pitchFamily="34" charset="-122"/>
                 <a:cs typeface="Arial" pitchFamily="34" charset="-120"/>
               </a:rPr>
-              <a:t>Van obima (nedostatak vremena): plaćene kampanje, kontinuirano vođenje mreža, e-mail marketing, loyalty program.</a:t>
+              <a:t>Van obima, ostavljeno za buduću saradnju: plaćene kampanje, kontinuirano vođenje mreža, e-mail marketing, loyalty program.</a:t>
             </a:r>
             <a:endParaRPr lang="en-US" sz="1100" dirty="0"/>
           </a:p>

</xml_diff>